<commit_message>
Add personal author logo to course slides and viewing PDF
</commit_message>
<xml_diff>
--- a/slides/00_Course_Setup_v1.3.pptx
+++ b/slides/00_Course_Setup_v1.3.pptx
@@ -2787,306 +2787,385 @@
 </file>
 
 <file path=ppt/slideMasters/slideMaster1.xml><?xml version="1.0" encoding="utf-8"?>
-<ns0:sldMaster xmlns:ns0="http://schemas.openxmlformats.org/presentationml/2006/main" xmlns:ns1="http://schemas.openxmlformats.org/drawingml/2006/main" xmlns:ns2="http://schemas.openxmlformats.org/officeDocument/2006/relationships">
-  <ns0:cSld name="Master">
-    <ns0:bg>
-      <ns0:bgRef idx="1001">
-        <ns1:schemeClr val="bg1"/>
-      </ns0:bgRef>
-    </ns0:bg>
-    <ns0:spTree>
-      <ns0:nvGrpSpPr>
-        <ns0:cNvPr id="1" name=""/>
-        <ns0:cNvGrpSpPr/>
-        <ns0:nvPr/>
-      </ns0:nvGrpSpPr>
-      <ns0:grpSpPr>
-        <ns1:xfrm/>
-      </ns0:grpSpPr>
-    </ns0:spTree>
-  </ns0:cSld>
-  <ns0:clrMap bg1="lt1" tx1="dk1" bg2="lt2" tx2="dk2" accent1="accent1" accent2="accent2" accent3="accent3" accent4="accent4" accent5="accent5" accent6="accent6" hlink="hlink" folHlink="folHlink"/>
-  <ns0:sldLayoutIdLst>
-    <ns0:sldLayoutId id="2147483649" ns2:id="R63f58260e12e40b2"/>
-  </ns0:sldLayoutIdLst>
-  <ns0:txStyles>
-    <ns0:titleStyle>
-      <ns1:lvl1pPr algn="l">
-        <ns1:lnSpc>
-          <ns1:spcPct val="90000"/>
-        </ns1:lnSpc>
-        <ns1:spcBef>
-          <ns1:spcPts val="0"/>
-        </ns1:spcBef>
-        <ns1:buNone/>
-        <ns1:defRPr sz="4400">
-          <ns1:solidFill>
-            <ns1:schemeClr val="tx1"/>
-          </ns1:solidFill>
-          <ns1:latin typeface="Meiryo"/>
-          <ns1:ea typeface="Meiryo"/>
-          <ns1:cs typeface="Meiryo"/>
-        </ns1:defRPr>
-      </ns1:lvl1pPr>
-    </ns0:titleStyle>
-    <ns0:bodyStyle>
-      <ns1:lvl1pPr marL="228600" indent="-228600" algn="l">
-        <ns1:lnSpc>
-          <ns1:spcPct val="90000"/>
-        </ns1:lnSpc>
-        <ns1:spcBef>
-          <ns1:spcPts val="1000"/>
-        </ns1:spcBef>
-        <ns1:buChar char="•"/>
-        <ns1:defRPr sz="2800">
-          <ns1:solidFill>
-            <ns1:schemeClr val="tx1"/>
-          </ns1:solidFill>
-          <ns1:latin typeface="Meiryo"/>
-          <ns1:ea typeface="Meiryo"/>
-          <ns1:cs typeface="Meiryo"/>
-        </ns1:defRPr>
-      </ns1:lvl1pPr>
-      <ns1:lvl2pPr marL="685800" indent="-228600" algn="l">
-        <ns1:lnSpc>
-          <ns1:spcPct val="90000"/>
-        </ns1:lnSpc>
-        <ns1:spcBef>
-          <ns1:spcPts val="500"/>
-        </ns1:spcBef>
-        <ns1:buChar char="•"/>
-        <ns1:defRPr sz="2400">
-          <ns1:solidFill>
-            <ns1:schemeClr val="tx1"/>
-          </ns1:solidFill>
-          <ns1:latin typeface="Meiryo"/>
-          <ns1:ea typeface="Meiryo"/>
-          <ns1:cs typeface="Meiryo"/>
-        </ns1:defRPr>
-      </ns1:lvl2pPr>
-      <ns1:lvl3pPr marL="1143000" indent="-228600" algn="l">
-        <ns1:lnSpc>
-          <ns1:spcPct val="90000"/>
-        </ns1:lnSpc>
-        <ns1:spcBef>
-          <ns1:spcPts val="500"/>
-        </ns1:spcBef>
-        <ns1:buChar char="•"/>
-        <ns1:defRPr sz="2000">
-          <ns1:solidFill>
-            <ns1:schemeClr val="tx1"/>
-          </ns1:solidFill>
-          <ns1:latin typeface="Meiryo"/>
-          <ns1:ea typeface="Meiryo"/>
-          <ns1:cs typeface="Meiryo"/>
-        </ns1:defRPr>
-      </ns1:lvl3pPr>
-      <ns1:lvl4pPr marL="1600200" indent="-228600" algn="l">
-        <ns1:lnSpc>
-          <ns1:spcPct val="90000"/>
-        </ns1:lnSpc>
-        <ns1:spcBef>
-          <ns1:spcPts val="500"/>
-        </ns1:spcBef>
-        <ns1:buChar char="•"/>
-        <ns1:defRPr sz="1800">
-          <ns1:solidFill>
-            <ns1:schemeClr val="tx1"/>
-          </ns1:solidFill>
-          <ns1:latin typeface="Meiryo"/>
-          <ns1:ea typeface="Meiryo"/>
-          <ns1:cs typeface="Meiryo"/>
-        </ns1:defRPr>
-      </ns1:lvl4pPr>
-      <ns1:lvl5pPr marL="2057400" indent="-228600" algn="l">
-        <ns1:lnSpc>
-          <ns1:spcPct val="90000"/>
-        </ns1:lnSpc>
-        <ns1:spcBef>
-          <ns1:spcPts val="500"/>
-        </ns1:spcBef>
-        <ns1:buChar char="•"/>
-        <ns1:defRPr sz="1800">
-          <ns1:solidFill>
-            <ns1:schemeClr val="tx1"/>
-          </ns1:solidFill>
-          <ns1:latin typeface="Meiryo"/>
-          <ns1:ea typeface="Meiryo"/>
-          <ns1:cs typeface="Meiryo"/>
-        </ns1:defRPr>
-      </ns1:lvl5pPr>
-      <ns1:lvl6pPr marL="2514600" indent="-228600" algn="l">
-        <ns1:lnSpc>
-          <ns1:spcPct val="90000"/>
-        </ns1:lnSpc>
-        <ns1:spcBef>
-          <ns1:spcPts val="500"/>
-        </ns1:spcBef>
-        <ns1:buChar char="•"/>
-        <ns1:defRPr sz="1800">
-          <ns1:solidFill>
-            <ns1:schemeClr val="tx1"/>
-          </ns1:solidFill>
-          <ns1:latin typeface="Meiryo"/>
-          <ns1:ea typeface="Meiryo"/>
-          <ns1:cs typeface="Meiryo"/>
-        </ns1:defRPr>
-      </ns1:lvl6pPr>
-      <ns1:lvl7pPr marL="2971800" indent="-228600" algn="l">
-        <ns1:lnSpc>
-          <ns1:spcPct val="90000"/>
-        </ns1:lnSpc>
-        <ns1:spcBef>
-          <ns1:spcPts val="500"/>
-        </ns1:spcBef>
-        <ns1:buChar char="•"/>
-        <ns1:defRPr sz="1800">
-          <ns1:solidFill>
-            <ns1:schemeClr val="tx1"/>
-          </ns1:solidFill>
-          <ns1:latin typeface="Meiryo"/>
-          <ns1:ea typeface="Meiryo"/>
-          <ns1:cs typeface="Meiryo"/>
-        </ns1:defRPr>
-      </ns1:lvl7pPr>
-      <ns1:lvl8pPr marL="3429000" indent="-228600" algn="l">
-        <ns1:lnSpc>
-          <ns1:spcPct val="90000"/>
-        </ns1:lnSpc>
-        <ns1:spcBef>
-          <ns1:spcPts val="500"/>
-        </ns1:spcBef>
-        <ns1:buChar char="•"/>
-        <ns1:defRPr sz="1800">
-          <ns1:solidFill>
-            <ns1:schemeClr val="tx1"/>
-          </ns1:solidFill>
-          <ns1:latin typeface="Meiryo"/>
-          <ns1:ea typeface="Meiryo"/>
-          <ns1:cs typeface="Meiryo"/>
-        </ns1:defRPr>
-      </ns1:lvl8pPr>
-      <ns1:lvl9pPr marL="3886200" indent="-228600" algn="l">
-        <ns1:lnSpc>
-          <ns1:spcPct val="90000"/>
-        </ns1:lnSpc>
-        <ns1:spcBef>
-          <ns1:spcPts val="500"/>
-        </ns1:spcBef>
-        <ns1:buChar char="•"/>
-        <ns1:defRPr sz="1800">
-          <ns1:solidFill>
-            <ns1:schemeClr val="tx1"/>
-          </ns1:solidFill>
-          <ns1:latin typeface="Meiryo"/>
-          <ns1:ea typeface="Meiryo"/>
-          <ns1:cs typeface="Meiryo"/>
-        </ns1:defRPr>
-      </ns1:lvl9pPr>
-    </ns0:bodyStyle>
-    <ns0:otherStyle>
-      <ns1:lvl1pPr marL="0" algn="l">
-        <ns1:buNone/>
-        <ns1:defRPr sz="1800">
-          <ns1:solidFill>
-            <ns1:schemeClr val="tx1"/>
-          </ns1:solidFill>
-          <ns1:latin typeface="Meiryo"/>
-          <ns1:ea typeface="Meiryo"/>
-          <ns1:cs typeface="Meiryo"/>
-        </ns1:defRPr>
-      </ns1:lvl1pPr>
-      <ns1:lvl2pPr marL="457200" algn="l">
-        <ns1:buNone/>
-        <ns1:defRPr sz="1800">
-          <ns1:solidFill>
-            <ns1:schemeClr val="tx1"/>
-          </ns1:solidFill>
-          <ns1:latin typeface="Meiryo"/>
-          <ns1:ea typeface="Meiryo"/>
-          <ns1:cs typeface="Meiryo"/>
-        </ns1:defRPr>
-      </ns1:lvl2pPr>
-      <ns1:lvl3pPr marL="914400" algn="l">
-        <ns1:buNone/>
-        <ns1:defRPr sz="1800">
-          <ns1:solidFill>
-            <ns1:schemeClr val="tx1"/>
-          </ns1:solidFill>
-          <ns1:latin typeface="Meiryo"/>
-          <ns1:ea typeface="Meiryo"/>
-          <ns1:cs typeface="Meiryo"/>
-        </ns1:defRPr>
-      </ns1:lvl3pPr>
-      <ns1:lvl4pPr marL="1371600" algn="l">
-        <ns1:buNone/>
-        <ns1:defRPr sz="1800">
-          <ns1:solidFill>
-            <ns1:schemeClr val="tx1"/>
-          </ns1:solidFill>
-          <ns1:latin typeface="Meiryo"/>
-          <ns1:ea typeface="Meiryo"/>
-          <ns1:cs typeface="Meiryo"/>
-        </ns1:defRPr>
-      </ns1:lvl4pPr>
-      <ns1:lvl5pPr marL="1828800" algn="l">
-        <ns1:buNone/>
-        <ns1:defRPr sz="1800">
-          <ns1:solidFill>
-            <ns1:schemeClr val="tx1"/>
-          </ns1:solidFill>
-          <ns1:latin typeface="Meiryo"/>
-          <ns1:ea typeface="Meiryo"/>
-          <ns1:cs typeface="Meiryo"/>
-        </ns1:defRPr>
-      </ns1:lvl5pPr>
-      <ns1:lvl6pPr marL="2286000" algn="l">
-        <ns1:buNone/>
-        <ns1:defRPr sz="1800">
-          <ns1:solidFill>
-            <ns1:schemeClr val="tx1"/>
-          </ns1:solidFill>
-          <ns1:latin typeface="Meiryo"/>
-          <ns1:ea typeface="Meiryo"/>
-          <ns1:cs typeface="Meiryo"/>
-        </ns1:defRPr>
-      </ns1:lvl6pPr>
-      <ns1:lvl7pPr marL="2743200" algn="l">
-        <ns1:buNone/>
-        <ns1:defRPr sz="1800">
-          <ns1:solidFill>
-            <ns1:schemeClr val="tx1"/>
-          </ns1:solidFill>
-          <ns1:latin typeface="Meiryo"/>
-          <ns1:ea typeface="Meiryo"/>
-          <ns1:cs typeface="Meiryo"/>
-        </ns1:defRPr>
-      </ns1:lvl7pPr>
-      <ns1:lvl8pPr marL="3200400" algn="l">
-        <ns1:buNone/>
-        <ns1:defRPr sz="1800">
-          <ns1:solidFill>
-            <ns1:schemeClr val="tx1"/>
-          </ns1:solidFill>
-          <ns1:latin typeface="Meiryo"/>
-          <ns1:ea typeface="Meiryo"/>
-          <ns1:cs typeface="Meiryo"/>
-        </ns1:defRPr>
-      </ns1:lvl8pPr>
-      <ns1:lvl9pPr marL="3657600" algn="l">
-        <ns1:buNone/>
-        <ns1:defRPr sz="1800">
-          <ns1:solidFill>
-            <ns1:schemeClr val="tx1"/>
-          </ns1:solidFill>
-          <ns1:latin typeface="Meiryo"/>
-          <ns1:ea typeface="Meiryo"/>
-          <ns1:cs typeface="Meiryo"/>
-        </ns1:defRPr>
-      </ns1:lvl9pPr>
-    </ns0:otherStyle>
-  </ns0:txStyles>
-</ns0:sldMaster>
+<p:sldMaster xmlns:a="http://schemas.openxmlformats.org/drawingml/2006/main" xmlns:ns3="http://schemas.microsoft.com/office/drawing/2014/main" xmlns:p="http://schemas.openxmlformats.org/presentationml/2006/main" xmlns:r="http://schemas.openxmlformats.org/officeDocument/2006/relationships">
+  <p:cSld name="Master">
+    <p:bg>
+      <p:bgRef idx="1001">
+        <a:schemeClr val="bg1"/>
+      </p:bgRef>
+    </p:bg>
+    <p:spTree>
+      <p:nvGrpSpPr>
+        <p:cNvPr id="1" name=""/>
+        <p:cNvGrpSpPr/>
+        <p:nvPr/>
+      </p:nvGrpSpPr>
+      <p:grpSpPr>
+        <a:xfrm/>
+      </p:grpSpPr>
+      <p:pic>
+        <p:nvPicPr>
+          <p:cNvPr id="2" name=""/>
+          <p:cNvPicPr>
+            <a:picLocks noChangeAspect="1"/>
+          </p:cNvPicPr>
+          <p:nvPr/>
+        </p:nvPicPr>
+        <p:blipFill>
+          <a:blip r:embed="rIdPersonalAuthorLogo"/>
+          <a:stretch/>
+        </p:blipFill>
+        <p:spPr>
+          <a:xfrm>
+            <a:off x="685800" y="85748"/>
+            <a:ext cx="1714500" cy="210457"/>
+          </a:xfrm>
+          <a:prstGeom prst="rect">
+            <a:avLst/>
+          </a:prstGeom>
+        </p:spPr>
+      </p:pic>
+      <p:sp>
+        <p:nvSpPr>
+          <p:cNvPr id="3" name="Personal author website">
+            <a:extLst>
+              <a:ext uri="{FF2B5EF4-FFF2-40B4-BE49-F238E27FC236}">
+                <ns3:creationId id="{8162AA9C-DED1-46B9-B7AB-42DB995DE4B9}"/>
+              </a:ext>
+            </a:extLst>
+          </p:cNvPr>
+          <p:cNvSpPr>
+            <a:spLocks noGrp="1"/>
+          </p:cNvSpPr>
+          <p:nvPr/>
+        </p:nvSpPr>
+        <p:spPr>
+          <a:xfrm>
+            <a:off x="6286500" y="6477000"/>
+            <a:ext cx="4000500" cy="266700"/>
+          </a:xfrm>
+          <a:prstGeom prst="rect">
+            <a:avLst/>
+          </a:prstGeom>
+          <a:noFill/>
+          <a:ln w="0">
+            <a:noFill/>
+          </a:ln>
+        </p:spPr>
+        <p:txBody>
+          <a:bodyPr>
+            <a:noAutofit/>
+          </a:bodyPr>
+          <a:lstStyle/>
+          <a:p>
+            <a:pPr>
+              <a:defRPr sz="1800">
+                <a:solidFill>
+                  <a:srgbClr val="607482"/>
+                </a:solidFill>
+                <a:latin typeface="Meiryo"/>
+                <a:ea typeface="Meiryo"/>
+                <a:cs typeface="Meiryo"/>
+              </a:defRPr>
+            </a:pPr>
+            <a:r>
+              <a:rPr sz="1800">
+                <a:solidFill>
+                  <a:srgbClr val="607482"/>
+                </a:solidFill>
+                <a:latin typeface="Meiryo"/>
+                <a:ea typeface="Meiryo"/>
+                <a:cs typeface="Meiryo"/>
+              </a:rPr>
+              <a:t>tsuchiyatakahiro.com</a:t>
+            </a:r>
+          </a:p>
+        </p:txBody>
+      </p:sp>
+    </p:spTree>
+  </p:cSld>
+  <p:clrMap bg1="lt1" tx1="dk1" bg2="lt2" tx2="dk2" accent1="accent1" accent2="accent2" accent3="accent3" accent4="accent4" accent5="accent5" accent6="accent6" hlink="hlink" folHlink="folHlink"/>
+  <p:sldLayoutIdLst>
+    <p:sldLayoutId id="2147483649" r:id="R63f58260e12e40b2"/>
+  </p:sldLayoutIdLst>
+  <p:txStyles>
+    <p:titleStyle>
+      <a:lvl1pPr algn="l">
+        <a:lnSpc>
+          <a:spcPct val="90000"/>
+        </a:lnSpc>
+        <a:spcBef>
+          <a:spcPts val="0"/>
+        </a:spcBef>
+        <a:buNone/>
+        <a:defRPr sz="4400">
+          <a:solidFill>
+            <a:schemeClr val="tx1"/>
+          </a:solidFill>
+          <a:latin typeface="Meiryo"/>
+          <a:ea typeface="Meiryo"/>
+          <a:cs typeface="Meiryo"/>
+        </a:defRPr>
+      </a:lvl1pPr>
+    </p:titleStyle>
+    <p:bodyStyle>
+      <a:lvl1pPr marL="228600" indent="-228600" algn="l">
+        <a:lnSpc>
+          <a:spcPct val="90000"/>
+        </a:lnSpc>
+        <a:spcBef>
+          <a:spcPts val="1000"/>
+        </a:spcBef>
+        <a:buChar char="•"/>
+        <a:defRPr sz="2800">
+          <a:solidFill>
+            <a:schemeClr val="tx1"/>
+          </a:solidFill>
+          <a:latin typeface="Meiryo"/>
+          <a:ea typeface="Meiryo"/>
+          <a:cs typeface="Meiryo"/>
+        </a:defRPr>
+      </a:lvl1pPr>
+      <a:lvl2pPr marL="685800" indent="-228600" algn="l">
+        <a:lnSpc>
+          <a:spcPct val="90000"/>
+        </a:lnSpc>
+        <a:spcBef>
+          <a:spcPts val="500"/>
+        </a:spcBef>
+        <a:buChar char="•"/>
+        <a:defRPr sz="2400">
+          <a:solidFill>
+            <a:schemeClr val="tx1"/>
+          </a:solidFill>
+          <a:latin typeface="Meiryo"/>
+          <a:ea typeface="Meiryo"/>
+          <a:cs typeface="Meiryo"/>
+        </a:defRPr>
+      </a:lvl2pPr>
+      <a:lvl3pPr marL="1143000" indent="-228600" algn="l">
+        <a:lnSpc>
+          <a:spcPct val="90000"/>
+        </a:lnSpc>
+        <a:spcBef>
+          <a:spcPts val="500"/>
+        </a:spcBef>
+        <a:buChar char="•"/>
+        <a:defRPr sz="2000">
+          <a:solidFill>
+            <a:schemeClr val="tx1"/>
+          </a:solidFill>
+          <a:latin typeface="Meiryo"/>
+          <a:ea typeface="Meiryo"/>
+          <a:cs typeface="Meiryo"/>
+        </a:defRPr>
+      </a:lvl3pPr>
+      <a:lvl4pPr marL="1600200" indent="-228600" algn="l">
+        <a:lnSpc>
+          <a:spcPct val="90000"/>
+        </a:lnSpc>
+        <a:spcBef>
+          <a:spcPts val="500"/>
+        </a:spcBef>
+        <a:buChar char="•"/>
+        <a:defRPr sz="1800">
+          <a:solidFill>
+            <a:schemeClr val="tx1"/>
+          </a:solidFill>
+          <a:latin typeface="Meiryo"/>
+          <a:ea typeface="Meiryo"/>
+          <a:cs typeface="Meiryo"/>
+        </a:defRPr>
+      </a:lvl4pPr>
+      <a:lvl5pPr marL="2057400" indent="-228600" algn="l">
+        <a:lnSpc>
+          <a:spcPct val="90000"/>
+        </a:lnSpc>
+        <a:spcBef>
+          <a:spcPts val="500"/>
+        </a:spcBef>
+        <a:buChar char="•"/>
+        <a:defRPr sz="1800">
+          <a:solidFill>
+            <a:schemeClr val="tx1"/>
+          </a:solidFill>
+          <a:latin typeface="Meiryo"/>
+          <a:ea typeface="Meiryo"/>
+          <a:cs typeface="Meiryo"/>
+        </a:defRPr>
+      </a:lvl5pPr>
+      <a:lvl6pPr marL="2514600" indent="-228600" algn="l">
+        <a:lnSpc>
+          <a:spcPct val="90000"/>
+        </a:lnSpc>
+        <a:spcBef>
+          <a:spcPts val="500"/>
+        </a:spcBef>
+        <a:buChar char="•"/>
+        <a:defRPr sz="1800">
+          <a:solidFill>
+            <a:schemeClr val="tx1"/>
+          </a:solidFill>
+          <a:latin typeface="Meiryo"/>
+          <a:ea typeface="Meiryo"/>
+          <a:cs typeface="Meiryo"/>
+        </a:defRPr>
+      </a:lvl6pPr>
+      <a:lvl7pPr marL="2971800" indent="-228600" algn="l">
+        <a:lnSpc>
+          <a:spcPct val="90000"/>
+        </a:lnSpc>
+        <a:spcBef>
+          <a:spcPts val="500"/>
+        </a:spcBef>
+        <a:buChar char="•"/>
+        <a:defRPr sz="1800">
+          <a:solidFill>
+            <a:schemeClr val="tx1"/>
+          </a:solidFill>
+          <a:latin typeface="Meiryo"/>
+          <a:ea typeface="Meiryo"/>
+          <a:cs typeface="Meiryo"/>
+        </a:defRPr>
+      </a:lvl7pPr>
+      <a:lvl8pPr marL="3429000" indent="-228600" algn="l">
+        <a:lnSpc>
+          <a:spcPct val="90000"/>
+        </a:lnSpc>
+        <a:spcBef>
+          <a:spcPts val="500"/>
+        </a:spcBef>
+        <a:buChar char="•"/>
+        <a:defRPr sz="1800">
+          <a:solidFill>
+            <a:schemeClr val="tx1"/>
+          </a:solidFill>
+          <a:latin typeface="Meiryo"/>
+          <a:ea typeface="Meiryo"/>
+          <a:cs typeface="Meiryo"/>
+        </a:defRPr>
+      </a:lvl8pPr>
+      <a:lvl9pPr marL="3886200" indent="-228600" algn="l">
+        <a:lnSpc>
+          <a:spcPct val="90000"/>
+        </a:lnSpc>
+        <a:spcBef>
+          <a:spcPts val="500"/>
+        </a:spcBef>
+        <a:buChar char="•"/>
+        <a:defRPr sz="1800">
+          <a:solidFill>
+            <a:schemeClr val="tx1"/>
+          </a:solidFill>
+          <a:latin typeface="Meiryo"/>
+          <a:ea typeface="Meiryo"/>
+          <a:cs typeface="Meiryo"/>
+        </a:defRPr>
+      </a:lvl9pPr>
+    </p:bodyStyle>
+    <p:otherStyle>
+      <a:lvl1pPr marL="0" algn="l">
+        <a:buNone/>
+        <a:defRPr sz="1800">
+          <a:solidFill>
+            <a:schemeClr val="tx1"/>
+          </a:solidFill>
+          <a:latin typeface="Meiryo"/>
+          <a:ea typeface="Meiryo"/>
+          <a:cs typeface="Meiryo"/>
+        </a:defRPr>
+      </a:lvl1pPr>
+      <a:lvl2pPr marL="457200" algn="l">
+        <a:buNone/>
+        <a:defRPr sz="1800">
+          <a:solidFill>
+            <a:schemeClr val="tx1"/>
+          </a:solidFill>
+          <a:latin typeface="Meiryo"/>
+          <a:ea typeface="Meiryo"/>
+          <a:cs typeface="Meiryo"/>
+        </a:defRPr>
+      </a:lvl2pPr>
+      <a:lvl3pPr marL="914400" algn="l">
+        <a:buNone/>
+        <a:defRPr sz="1800">
+          <a:solidFill>
+            <a:schemeClr val="tx1"/>
+          </a:solidFill>
+          <a:latin typeface="Meiryo"/>
+          <a:ea typeface="Meiryo"/>
+          <a:cs typeface="Meiryo"/>
+        </a:defRPr>
+      </a:lvl3pPr>
+      <a:lvl4pPr marL="1371600" algn="l">
+        <a:buNone/>
+        <a:defRPr sz="1800">
+          <a:solidFill>
+            <a:schemeClr val="tx1"/>
+          </a:solidFill>
+          <a:latin typeface="Meiryo"/>
+          <a:ea typeface="Meiryo"/>
+          <a:cs typeface="Meiryo"/>
+        </a:defRPr>
+      </a:lvl4pPr>
+      <a:lvl5pPr marL="1828800" algn="l">
+        <a:buNone/>
+        <a:defRPr sz="1800">
+          <a:solidFill>
+            <a:schemeClr val="tx1"/>
+          </a:solidFill>
+          <a:latin typeface="Meiryo"/>
+          <a:ea typeface="Meiryo"/>
+          <a:cs typeface="Meiryo"/>
+        </a:defRPr>
+      </a:lvl5pPr>
+      <a:lvl6pPr marL="2286000" algn="l">
+        <a:buNone/>
+        <a:defRPr sz="1800">
+          <a:solidFill>
+            <a:schemeClr val="tx1"/>
+          </a:solidFill>
+          <a:latin typeface="Meiryo"/>
+          <a:ea typeface="Meiryo"/>
+          <a:cs typeface="Meiryo"/>
+        </a:defRPr>
+      </a:lvl6pPr>
+      <a:lvl7pPr marL="2743200" algn="l">
+        <a:buNone/>
+        <a:defRPr sz="1800">
+          <a:solidFill>
+            <a:schemeClr val="tx1"/>
+          </a:solidFill>
+          <a:latin typeface="Meiryo"/>
+          <a:ea typeface="Meiryo"/>
+          <a:cs typeface="Meiryo"/>
+        </a:defRPr>
+      </a:lvl7pPr>
+      <a:lvl8pPr marL="3200400" algn="l">
+        <a:buNone/>
+        <a:defRPr sz="1800">
+          <a:solidFill>
+            <a:schemeClr val="tx1"/>
+          </a:solidFill>
+          <a:latin typeface="Meiryo"/>
+          <a:ea typeface="Meiryo"/>
+          <a:cs typeface="Meiryo"/>
+        </a:defRPr>
+      </a:lvl8pPr>
+      <a:lvl9pPr marL="3657600" algn="l">
+        <a:buNone/>
+        <a:defRPr sz="1800">
+          <a:solidFill>
+            <a:schemeClr val="tx1"/>
+          </a:solidFill>
+          <a:latin typeface="Meiryo"/>
+          <a:ea typeface="Meiryo"/>
+          <a:cs typeface="Meiryo"/>
+        </a:defRPr>
+      </a:lvl9pPr>
+    </p:otherStyle>
+  </p:txStyles>
+</p:sldMaster>
 </file>
 
 <file path=ppt/slideMasters/theme/theme2.xml><?xml version="1.0" encoding="utf-8"?>

</xml_diff>